<commit_message>
Add Paths Explored slide and update context with team assignments
</commit_message>
<xml_diff>
--- a/docs/Capstone_Presentation.pptx
+++ b/docs/Capstone_Presentation.pptx
@@ -17,6 +17,7 @@
     <p:sldId id="262" r:id="rId33"/>
     <p:sldId id="263" r:id="rId34"/>
     <p:sldId id="264" r:id="rId35"/>
+    <p:sldId id="280" r:id="rId12"/>
     <p:sldId id="265" r:id="rId36"/>
     <p:sldId id="266" r:id="rId26"/>
     <p:sldId id="267" r:id="rId25"/>
@@ -12435,6 +12436,683 @@
                 </a:solidFill>
               </a:rPr>
               <a:t>[Describe corrections made, things that required manual verification, etc.]</a:t>
+            </a:r>
+          </a:p>
+        </p:txBody>
+      </p:sp>
+    </p:spTree>
+  </p:cSld>
+  <p:clrMapOvr>
+    <a:masterClrMapping/>
+  </p:clrMapOvr>
+</p:sld>
+</file>
+
+<file path=ppt/slides/slide25.xml><?xml version="1.0" encoding="utf-8"?>
+<p:sld xmlns:a="http://schemas.openxmlformats.org/drawingml/2006/main" xmlns:p="http://schemas.openxmlformats.org/presentationml/2006/main" xmlns:r="http://schemas.openxmlformats.org/officeDocument/2006/relationships">
+  <p:cSld>
+    <p:spTree>
+      <p:nvGrpSpPr>
+        <p:cNvPr id="1" name=""/>
+        <p:cNvGrpSpPr/>
+        <p:nvPr/>
+      </p:nvGrpSpPr>
+      <p:grpSpPr/>
+      <p:sp>
+        <p:nvSpPr>
+          <p:cNvPr id="2" name="Title 1"/>
+          <p:cNvSpPr>
+            <a:spLocks noGrp="1"/>
+          </p:cNvSpPr>
+          <p:nvPr>
+            <p:ph type="title"/>
+          </p:nvPr>
+        </p:nvSpPr>
+        <p:spPr/>
+        <p:txBody>
+          <a:bodyPr/>
+          <a:lstStyle/>
+          <a:p>
+            <a:r>
+              <a:t>Paths We Explored</a:t>
+            </a:r>
+          </a:p>
+        </p:txBody>
+      </p:sp>
+      <p:sp>
+        <p:nvSpPr>
+          <p:cNvPr id="3" name="Content Placeholder 2"/>
+          <p:cNvSpPr>
+            <a:spLocks noGrp="1"/>
+          </p:cNvSpPr>
+          <p:nvPr>
+            <p:ph idx="1"/>
+          </p:nvPr>
+        </p:nvSpPr>
+        <p:spPr/>
+        <p:txBody>
+          <a:bodyPr/>
+          <a:lstStyle/>
+          <a:p/>
+        </p:txBody>
+      </p:sp>
+      <p:sp>
+        <p:nvSpPr>
+          <p:cNvPr id="4" name="Rectangle 3"/>
+          <p:cNvSpPr/>
+          <p:nvPr/>
+        </p:nvSpPr>
+        <p:spPr>
+          <a:xfrm>
+            <a:off x="0" y="800000"/>
+            <a:ext cx="12192000" cy="80000"/>
+          </a:xfrm>
+          <a:prstGeom prst="rect">
+            <a:avLst/>
+          </a:prstGeom>
+          <a:solidFill>
+            <a:srgbClr val="FE3082"/>
+          </a:solidFill>
+          <a:ln>
+            <a:noFill/>
+          </a:ln>
+        </p:spPr>
+        <p:style>
+          <a:lnRef idx="1">
+            <a:schemeClr val="accent1"/>
+          </a:lnRef>
+          <a:fillRef idx="3">
+            <a:schemeClr val="accent1"/>
+          </a:fillRef>
+          <a:effectRef idx="2">
+            <a:schemeClr val="accent1"/>
+          </a:effectRef>
+          <a:fontRef idx="minor">
+            <a:schemeClr val="lt1"/>
+          </a:fontRef>
+        </p:style>
+        <p:txBody>
+          <a:bodyPr rtlCol="0" anchor="ctr"/>
+          <a:lstStyle/>
+          <a:p>
+            <a:pPr algn="ctr"/>
+          </a:p>
+        </p:txBody>
+      </p:sp>
+      <p:sp>
+        <p:nvSpPr>
+          <p:cNvPr id="5" name="Rounded Rectangle 4"/>
+          <p:cNvSpPr/>
+          <p:nvPr/>
+        </p:nvSpPr>
+        <p:spPr>
+          <a:xfrm>
+            <a:off x="400000" y="1000000"/>
+            <a:ext cx="3500000" cy="2200000"/>
+          </a:xfrm>
+          <a:prstGeom prst="roundRect">
+            <a:avLst/>
+          </a:prstGeom>
+          <a:solidFill>
+            <a:srgbClr val="FFF3E0"/>
+          </a:solidFill>
+          <a:ln>
+            <a:noFill/>
+          </a:ln>
+        </p:spPr>
+        <p:style>
+          <a:lnRef idx="1">
+            <a:schemeClr val="accent1"/>
+          </a:lnRef>
+          <a:fillRef idx="3">
+            <a:schemeClr val="accent1"/>
+          </a:fillRef>
+          <a:effectRef idx="2">
+            <a:schemeClr val="accent1"/>
+          </a:effectRef>
+          <a:fontRef idx="minor">
+            <a:schemeClr val="lt1"/>
+          </a:fontRef>
+        </p:style>
+        <p:txBody>
+          <a:bodyPr rtlCol="0" anchor="ctr" wrap="square"/>
+          <a:lstStyle/>
+          <a:p>
+            <a:pPr algn="ctr"/>
+            <a:r>
+              <a:rPr sz="1600" b="1">
+                <a:solidFill>
+                  <a:srgbClr val="E65100"/>
+                </a:solidFill>
+              </a:rPr>
+              <a:t>Construction Data</a:t>
+            </a:r>
+          </a:p>
+          <a:p>
+            <a:pPr algn="ctr">
+              <a:spcBef>
+                <a:spcPts val="800"/>
+              </a:spcBef>
+            </a:pPr>
+            <a:r>
+              <a:rPr sz="1200" i="1">
+                <a:solidFill>
+                  <a:srgbClr val="555555"/>
+                </a:solidFill>
+              </a:rPr>
+              <a:t>Explored</a:t>
+            </a:r>
+          </a:p>
+          <a:p>
+            <a:pPr>
+              <a:spcBef>
+                <a:spcPts val="1200"/>
+              </a:spcBef>
+            </a:pPr>
+            <a:r>
+              <a:rPr sz="1100">
+                <a:solidFill>
+                  <a:srgbClr val="2D2D2D"/>
+                </a:solidFill>
+              </a:rPr>
+              <a:t>•  Investigated NYC construction data as enrichment</a:t>
+            </a:r>
+          </a:p>
+          <a:p>
+            <a:pPr>
+              <a:spcBef>
+                <a:spcPts val="400"/>
+              </a:spcBef>
+            </a:pPr>
+            <a:r>
+              <a:rPr sz="1100">
+                <a:solidFill>
+                  <a:srgbClr val="2D2D2D"/>
+                </a:solidFill>
+              </a:rPr>
+              <a:t>•  [Why we moved on: data quality, coverage, or relevance]</a:t>
+            </a:r>
+          </a:p>
+        </p:txBody>
+      </p:sp>
+      <p:sp>
+        <p:nvSpPr>
+          <p:cNvPr id="6" name="Rounded Rectangle 5"/>
+          <p:cNvSpPr/>
+          <p:nvPr/>
+        </p:nvSpPr>
+        <p:spPr>
+          <a:xfrm>
+            <a:off x="4200000" y="1000000"/>
+            <a:ext cx="3500000" cy="2200000"/>
+          </a:xfrm>
+          <a:prstGeom prst="roundRect">
+            <a:avLst/>
+          </a:prstGeom>
+          <a:solidFill>
+            <a:srgbClr val="E3F2FD"/>
+          </a:solidFill>
+          <a:ln>
+            <a:noFill/>
+          </a:ln>
+        </p:spPr>
+        <p:style>
+          <a:lnRef idx="1">
+            <a:schemeClr val="accent1"/>
+          </a:lnRef>
+          <a:fillRef idx="3">
+            <a:schemeClr val="accent1"/>
+          </a:fillRef>
+          <a:effectRef idx="2">
+            <a:schemeClr val="accent1"/>
+          </a:effectRef>
+          <a:fontRef idx="minor">
+            <a:schemeClr val="lt1"/>
+          </a:fontRef>
+        </p:style>
+        <p:txBody>
+          <a:bodyPr rtlCol="0" anchor="ctr" wrap="square"/>
+          <a:lstStyle/>
+          <a:p>
+            <a:pPr algn="ctr"/>
+            <a:r>
+              <a:rPr sz="1600" b="1">
+                <a:solidFill>
+                  <a:srgbClr val="0D47A1"/>
+                </a:solidFill>
+              </a:rPr>
+              <a:t>Pattern B (ETL)</a:t>
+            </a:r>
+          </a:p>
+          <a:p>
+            <a:pPr algn="ctr">
+              <a:spcBef>
+                <a:spcPts val="800"/>
+              </a:spcBef>
+            </a:pPr>
+            <a:r>
+              <a:rPr sz="1200" i="1">
+                <a:solidFill>
+                  <a:srgbClr val="555555"/>
+                </a:solidFill>
+              </a:rPr>
+              <a:t>Built and Tested</a:t>
+            </a:r>
+          </a:p>
+          <a:p>
+            <a:pPr>
+              <a:spcBef>
+                <a:spcPts val="1200"/>
+              </a:spcBef>
+            </a:pPr>
+            <a:r>
+              <a:rPr sz="1100">
+                <a:solidFill>
+                  <a:srgbClr val="2D2D2D"/>
+                </a:solidFill>
+              </a:rPr>
+              <a:t>•  AWS Glue + PySpark for Silver layer cleaning</a:t>
+            </a:r>
+          </a:p>
+          <a:p>
+            <a:pPr>
+              <a:spcBef>
+                <a:spcPts val="400"/>
+              </a:spcBef>
+            </a:pPr>
+            <a:r>
+              <a:rPr sz="1100">
+                <a:solidFill>
+                  <a:srgbClr val="2D2D2D"/>
+                </a:solidFill>
+              </a:rPr>
+              <a:t>•  DataFrame transformations for data quality</a:t>
+            </a:r>
+          </a:p>
+          <a:p>
+            <a:pPr>
+              <a:spcBef>
+                <a:spcPts val="400"/>
+              </a:spcBef>
+            </a:pPr>
+            <a:r>
+              <a:rPr sz="1100">
+                <a:solidFill>
+                  <a:srgbClr val="2D2D2D"/>
+                </a:solidFill>
+              </a:rPr>
+              <a:t>•  [Additional Pattern B details]</a:t>
+            </a:r>
+          </a:p>
+        </p:txBody>
+      </p:sp>
+      <p:sp>
+        <p:nvSpPr>
+          <p:cNvPr id="7" name="Rounded Rectangle 6"/>
+          <p:cNvSpPr/>
+          <p:nvPr/>
+        </p:nvSpPr>
+        <p:spPr>
+          <a:xfrm>
+            <a:off x="8000000" y="1000000"/>
+            <a:ext cx="3500000" cy="2200000"/>
+          </a:xfrm>
+          <a:prstGeom prst="roundRect">
+            <a:avLst/>
+          </a:prstGeom>
+          <a:solidFill>
+            <a:srgbClr val="E8F5E9"/>
+          </a:solidFill>
+          <a:ln>
+            <a:noFill/>
+          </a:ln>
+        </p:spPr>
+        <p:style>
+          <a:lnRef idx="1">
+            <a:schemeClr val="accent1"/>
+          </a:lnRef>
+          <a:fillRef idx="3">
+            <a:schemeClr val="accent1"/>
+          </a:fillRef>
+          <a:effectRef idx="2">
+            <a:schemeClr val="accent1"/>
+          </a:effectRef>
+          <a:fontRef idx="minor">
+            <a:schemeClr val="lt1"/>
+          </a:fontRef>
+        </p:style>
+        <p:txBody>
+          <a:bodyPr rtlCol="0" anchor="ctr" wrap="square"/>
+          <a:lstStyle/>
+          <a:p>
+            <a:pPr algn="ctr"/>
+            <a:r>
+              <a:rPr sz="1600" b="1">
+                <a:solidFill>
+                  <a:srgbClr val="2E7D32"/>
+                </a:solidFill>
+              </a:rPr>
+              <a:t>Pattern A (ELT)</a:t>
+            </a:r>
+          </a:p>
+          <a:p>
+            <a:pPr algn="ctr">
+              <a:spcBef>
+                <a:spcPts val="800"/>
+              </a:spcBef>
+            </a:pPr>
+            <a:r>
+              <a:rPr sz="1200" b="1">
+                <a:solidFill>
+                  <a:srgbClr val="2E7D32"/>
+                </a:solidFill>
+              </a:rPr>
+              <a:t>Selected</a:t>
+            </a:r>
+          </a:p>
+          <a:p>
+            <a:pPr>
+              <a:spcBef>
+                <a:spcPts val="1200"/>
+              </a:spcBef>
+            </a:pPr>
+            <a:r>
+              <a:rPr sz="1100">
+                <a:solidFill>
+                  <a:srgbClr val="2D2D2D"/>
+                </a:solidFill>
+              </a:rPr>
+              <a:t>•  Snowflake + dbt, all SQL</a:t>
+            </a:r>
+          </a:p>
+          <a:p>
+            <a:pPr>
+              <a:spcBef>
+                <a:spcPts val="400"/>
+              </a:spcBef>
+            </a:pPr>
+            <a:r>
+              <a:rPr sz="1100">
+                <a:solidFill>
+                  <a:srgbClr val="2D2D2D"/>
+                </a:solidFill>
+              </a:rPr>
+              <a:t>•  Full pipeline in ~6 min, 32 tests passing</a:t>
+            </a:r>
+          </a:p>
+          <a:p>
+            <a:pPr>
+              <a:spcBef>
+                <a:spcPts val="400"/>
+              </a:spcBef>
+            </a:pPr>
+            <a:r>
+              <a:rPr sz="1100">
+                <a:solidFill>
+                  <a:srgbClr val="2D2D2D"/>
+                </a:solidFill>
+              </a:rPr>
+              <a:t>•  Idempotent, reproducible, tested</a:t>
+            </a:r>
+          </a:p>
+        </p:txBody>
+      </p:sp>
+      <p:sp>
+        <p:nvSpPr>
+          <p:cNvPr id="8" name="TextBox 7"/>
+          <p:cNvSpPr txBox="1"/>
+          <p:nvPr/>
+        </p:nvSpPr>
+        <p:spPr>
+          <a:xfrm>
+            <a:off x="3700000" y="1800000"/>
+            <a:ext cx="700000" cy="500000"/>
+          </a:xfrm>
+          <a:prstGeom prst="rect">
+            <a:avLst/>
+          </a:prstGeom>
+          <a:noFill/>
+        </p:spPr>
+        <p:txBody>
+          <a:bodyPr wrap="none">
+            <a:spAutoFit/>
+          </a:bodyPr>
+          <a:lstStyle/>
+          <a:p>
+            <a:pPr algn="ctr"/>
+            <a:r>
+              <a:rPr sz="3200" b="1">
+                <a:solidFill>
+                  <a:srgbClr val="FE3082"/>
+                </a:solidFill>
+              </a:rPr>
+              <a:t>→</a:t>
+            </a:r>
+          </a:p>
+        </p:txBody>
+      </p:sp>
+      <p:sp>
+        <p:nvSpPr>
+          <p:cNvPr id="9" name="TextBox 8"/>
+          <p:cNvSpPr txBox="1"/>
+          <p:nvPr/>
+        </p:nvSpPr>
+        <p:spPr>
+          <a:xfrm>
+            <a:off x="7500000" y="1800000"/>
+            <a:ext cx="700000" cy="500000"/>
+          </a:xfrm>
+          <a:prstGeom prst="rect">
+            <a:avLst/>
+          </a:prstGeom>
+          <a:noFill/>
+        </p:spPr>
+        <p:txBody>
+          <a:bodyPr wrap="none">
+            <a:spAutoFit/>
+          </a:bodyPr>
+          <a:lstStyle/>
+          <a:p>
+            <a:pPr algn="ctr"/>
+            <a:r>
+              <a:rPr sz="3200" b="1">
+                <a:solidFill>
+                  <a:srgbClr val="FE3082"/>
+                </a:solidFill>
+              </a:rPr>
+              <a:t>→</a:t>
+            </a:r>
+          </a:p>
+        </p:txBody>
+      </p:sp>
+      <p:sp>
+        <p:nvSpPr>
+          <p:cNvPr id="10" name="Rounded Rectangle 9"/>
+          <p:cNvSpPr/>
+          <p:nvPr/>
+        </p:nvSpPr>
+        <p:spPr>
+          <a:xfrm>
+            <a:off x="400000" y="3500000"/>
+            <a:ext cx="11400000" cy="1200000"/>
+          </a:xfrm>
+          <a:prstGeom prst="roundRect">
+            <a:avLst/>
+          </a:prstGeom>
+          <a:solidFill>
+            <a:srgbClr val="FCE4EC"/>
+          </a:solidFill>
+          <a:ln>
+            <a:noFill/>
+          </a:ln>
+        </p:spPr>
+        <p:style>
+          <a:lnRef idx="1">
+            <a:schemeClr val="accent1"/>
+          </a:lnRef>
+          <a:fillRef idx="3">
+            <a:schemeClr val="accent1"/>
+          </a:fillRef>
+          <a:effectRef idx="2">
+            <a:schemeClr val="accent1"/>
+          </a:effectRef>
+          <a:fontRef idx="minor">
+            <a:schemeClr val="lt1"/>
+          </a:fontRef>
+        </p:style>
+        <p:txBody>
+          <a:bodyPr rtlCol="0" anchor="ctr" wrap="square"/>
+          <a:lstStyle/>
+          <a:p>
+            <a:pPr algn="ctr"/>
+            <a:r>
+              <a:rPr sz="1400" b="1">
+                <a:solidFill>
+                  <a:srgbClr val="FE3082"/>
+                </a:solidFill>
+              </a:rPr>
+              <a:t>Why We Chose Pattern A</a:t>
+            </a:r>
+          </a:p>
+          <a:p>
+            <a:pPr>
+              <a:spcBef>
+                <a:spcPts val="600"/>
+              </a:spcBef>
+            </a:pPr>
+            <a:r>
+              <a:rPr sz="1200">
+                <a:solidFill>
+                  <a:srgbClr val="2D2D2D"/>
+                </a:solidFill>
+              </a:rPr>
+              <a:t>•  Strongest reliability guarantee within a one-week sprint (fewer moving parts, fewer failure modes)</a:t>
+            </a:r>
+          </a:p>
+          <a:p>
+            <a:pPr>
+              <a:spcBef>
+                <a:spcPts val="400"/>
+              </a:spcBef>
+            </a:pPr>
+            <a:r>
+              <a:rPr sz="1200">
+                <a:solidFill>
+                  <a:srgbClr val="2D2D2D"/>
+                </a:solidFill>
+              </a:rPr>
+              <a:t>•  Team's SQL strength meant faster iteration and easier debugging</a:t>
+            </a:r>
+          </a:p>
+          <a:p>
+            <a:pPr>
+              <a:spcBef>
+                <a:spcPts val="400"/>
+              </a:spcBef>
+            </a:pPr>
+            <a:r>
+              <a:rPr sz="1200">
+                <a:solidFill>
+                  <a:srgbClr val="2D2D2D"/>
+                </a:solidFill>
+              </a:rPr>
+              <a:t>•  All work from Pattern B exploration informed our data quality understanding</a:t>
+            </a:r>
+          </a:p>
+        </p:txBody>
+      </p:sp>
+      <p:sp>
+        <p:nvSpPr>
+          <p:cNvPr id="11" name="Rounded Rectangle 10"/>
+          <p:cNvSpPr/>
+          <p:nvPr/>
+        </p:nvSpPr>
+        <p:spPr>
+          <a:xfrm>
+            <a:off x="400000" y="5000000"/>
+            <a:ext cx="11400000" cy="1200000"/>
+          </a:xfrm>
+          <a:prstGeom prst="roundRect">
+            <a:avLst/>
+          </a:prstGeom>
+          <a:solidFill>
+            <a:srgbClr val="E3F2FD"/>
+          </a:solidFill>
+          <a:ln>
+            <a:noFill/>
+          </a:ln>
+        </p:spPr>
+        <p:style>
+          <a:lnRef idx="1">
+            <a:schemeClr val="accent1"/>
+          </a:lnRef>
+          <a:fillRef idx="3">
+            <a:schemeClr val="accent1"/>
+          </a:fillRef>
+          <a:effectRef idx="2">
+            <a:schemeClr val="accent1"/>
+          </a:effectRef>
+          <a:fontRef idx="minor">
+            <a:schemeClr val="lt1"/>
+          </a:fontRef>
+        </p:style>
+        <p:txBody>
+          <a:bodyPr rtlCol="0" anchor="ctr" wrap="square"/>
+          <a:lstStyle/>
+          <a:p>
+            <a:pPr algn="ctr"/>
+            <a:r>
+              <a:rPr sz="1400" b="1">
+                <a:solidFill>
+                  <a:srgbClr val="0D47A1"/>
+                </a:solidFill>
+              </a:rPr>
+              <a:t>What the Exploration Taught Us</a:t>
+            </a:r>
+          </a:p>
+          <a:p>
+            <a:pPr>
+              <a:spcBef>
+                <a:spcPts val="600"/>
+              </a:spcBef>
+            </a:pPr>
+            <a:r>
+              <a:rPr sz="1200">
+                <a:solidFill>
+                  <a:srgbClr val="2D2D2D"/>
+                </a:solidFill>
+              </a:rPr>
+              <a:t>•  [Insight from construction data exploration that influenced final approach]</a:t>
+            </a:r>
+          </a:p>
+          <a:p>
+            <a:pPr>
+              <a:spcBef>
+                <a:spcPts val="400"/>
+              </a:spcBef>
+            </a:pPr>
+            <a:r>
+              <a:rPr sz="1200">
+                <a:solidFill>
+                  <a:srgbClr val="2D2D2D"/>
+                </a:solidFill>
+              </a:rPr>
+              <a:t>•  [Insight from Pattern B work, e.g., data quality issues discovered during Spark cleaning]</a:t>
+            </a:r>
+          </a:p>
+          <a:p>
+            <a:pPr>
+              <a:spcBef>
+                <a:spcPts val="400"/>
+              </a:spcBef>
+            </a:pPr>
+            <a:r>
+              <a:rPr sz="1200">
+                <a:solidFill>
+                  <a:srgbClr val="2D2D2D"/>
+                </a:solidFill>
+              </a:rPr>
+              <a:t>•  [How exploring multiple paths made our final architecture decision more defensible]</a:t>
             </a:r>
           </a:p>
         </p:txBody>

</xml_diff>